<commit_message>
feat(14-01): attempt PPTX convert backend and add fixture
- Commit minimal valid 2-slide OOXML PPTX at scripts/fixtures/spike-deck.pptx
- Spike POSTs to Gotenberg contract when DECK_CONVERT_URL is set
- DECK_CONVERT_URL unset: exit 0 with unprovisioned message for Task 3 decision

Co-authored-by: Cursor <cursoragent@cursor.com>
</commit_message>
<xml_diff>
--- a/scripts/fixtures/spike-deck.pptx
+++ b/scripts/fixtures/spike-deck.pptx
@@ -2,17 +2,17 @@
 <file path=ppt/presentation.xml><?xml version="1.0" encoding="utf-8"?>
 <p:presentation xmlns:a="http://schemas.openxmlformats.org/drawingml/2006/main" xmlns:r="http://schemas.openxmlformats.org/officeDocument/2006/relationships" xmlns:p="http://schemas.openxmlformats.org/presentationml/2006/main">
   <p:sldIdLst>
-    <p:sldId id="256" r:id="rId1"/>
-    <p:sldId id="257" r:id="rId2"/>
+    <p:sldId id="256" r:id="rId2"/>
+    <p:sldId id="257" r:id="rId3"/>
   </p:sldIdLst>
-  <p:sldSz cx="12192000" cy="6858000"/>
+  <p:sldSz cx="9144000" cy="6858000"/>
   <p:notesSz cx="6858000" cy="9144000"/>
 </p:presentation>
 </file>
 
 <file path=ppt/slideLayouts/slideLayout1.xml><?xml version="1.0" encoding="utf-8"?>
 <p:sldLayout xmlns:a="http://schemas.openxmlformats.org/drawingml/2006/main" xmlns:r="http://schemas.openxmlformats.org/officeDocument/2006/relationships" xmlns:p="http://schemas.openxmlformats.org/presentationml/2006/main" type="blank" preserve="1">
-  <p:cSld>
+  <p:cSld name="Blank">
     <p:spTree>
       <p:nvGrpSpPr>
         <p:cNvPr id="1" name=""/>
@@ -22,6 +22,9 @@
       <p:grpSpPr/>
     </p:spTree>
   </p:cSld>
+  <p:clrMapOvr>
+    <a:masterClrMapping/>
+  </p:clrMapOvr>
 </p:sldLayout>
 </file>
 
@@ -29,11 +32,9 @@
 <p:sldMaster xmlns:a="http://schemas.openxmlformats.org/drawingml/2006/main" xmlns:r="http://schemas.openxmlformats.org/officeDocument/2006/relationships" xmlns:p="http://schemas.openxmlformats.org/presentationml/2006/main">
   <p:cSld>
     <p:bg>
-      <p:bgPr>
-        <a:solidFill>
-          <a:srgbClr val="FFFFFF"/>
-        </a:solidFill>
-      </p:bgPr>
+      <p:bgRef idx="1001">
+        <a:schemeClr val="bg1"/>
+      </p:bgRef>
     </p:bg>
     <p:spTree>
       <p:nvGrpSpPr>
@@ -64,16 +65,25 @@
       <p:sp>
         <p:nvSpPr>
           <p:cNvPr id="2" name="Title"/>
-          <p:cNvSpPr/>
+          <p:cNvSpPr txBox="1"/>
           <p:nvPr/>
         </p:nvSpPr>
-        <p:spPr/>
+        <p:spPr>
+          <a:xfrm>
+            <a:off x="457200" y="274320"/>
+            <a:ext cx="8229600" cy="1143000"/>
+          </a:xfrm>
+          <a:prstGeom prst="rect">
+            <a:avLst/>
+          </a:prstGeom>
+        </p:spPr>
         <p:txBody>
-          <a:bodyPr/>
+          <a:bodyPr wrap="square"/>
           <a:lstStyle/>
           <a:p>
             <a:r>
-              <a:t>Spike Deck Title</a:t>
+              <a:rPr lang="en-US" sz="3200" b="1"/>
+              <a:t>Spike Deck Slide 1</a:t>
             </a:r>
           </a:p>
         </p:txBody>
@@ -81,22 +91,38 @@
       <p:sp>
         <p:nvSpPr>
           <p:cNvPr id="3" name="Body"/>
-          <p:cNvSpPr/>
+          <p:cNvSpPr txBox="1"/>
           <p:nvPr/>
         </p:nvSpPr>
-        <p:spPr/>
+        <p:spPr>
+          <a:xfrm>
+            <a:off x="457200" y="1600200"/>
+            <a:ext cx="8229600" cy="4114800"/>
+          </a:xfrm>
+          <a:prstGeom prst="rect">
+            <a:avLst/>
+          </a:prstGeom>
+        </p:spPr>
         <p:txBody>
-          <a:bodyPr/>
+          <a:bodyPr wrap="square"/>
           <a:lstStyle/>
           <a:p>
+            <a:pPr marL="342900" indent="-342900">
+              <a:buFont typeface="Arial"/>
+              <a:buChar char="•"/>
+            </a:pPr>
             <a:r>
-              <a:t>Opening bullet about the product</a:t>
+              <a:rPr lang="en-US" sz="2000"/>
+              <a:t>Proof that OOXML PPTX converts via the backend</a:t>
             </a:r>
           </a:p>
         </p:txBody>
       </p:sp>
     </p:spTree>
   </p:cSld>
+  <p:clrMapOvr>
+    <a:masterClrMapping/>
+  </p:clrMapOvr>
 </p:sld>
 </file>
 
@@ -113,16 +139,25 @@
       <p:sp>
         <p:nvSpPr>
           <p:cNvPr id="2" name="Title"/>
-          <p:cNvSpPr/>
+          <p:cNvSpPr txBox="1"/>
           <p:nvPr/>
         </p:nvSpPr>
-        <p:spPr/>
+        <p:spPr>
+          <a:xfrm>
+            <a:off x="457200" y="274320"/>
+            <a:ext cx="8229600" cy="1143000"/>
+          </a:xfrm>
+          <a:prstGeom prst="rect">
+            <a:avLst/>
+          </a:prstGeom>
+        </p:spPr>
         <p:txBody>
-          <a:bodyPr/>
+          <a:bodyPr wrap="square"/>
           <a:lstStyle/>
           <a:p>
             <a:r>
-              <a:t>Market Opportunity</a:t>
+              <a:rPr lang="en-US" sz="3200" b="1"/>
+              <a:t>Spike Deck Slide 2</a:t>
             </a:r>
           </a:p>
         </p:txBody>
@@ -130,21 +165,146 @@
       <p:sp>
         <p:nvSpPr>
           <p:cNvPr id="3" name="Body"/>
-          <p:cNvSpPr/>
+          <p:cNvSpPr txBox="1"/>
           <p:nvPr/>
         </p:nvSpPr>
-        <p:spPr/>
+        <p:spPr>
+          <a:xfrm>
+            <a:off x="457200" y="1600200"/>
+            <a:ext cx="8229600" cy="4114800"/>
+          </a:xfrm>
+          <a:prstGeom prst="rect">
+            <a:avLst/>
+          </a:prstGeom>
+        </p:spPr>
         <p:txBody>
-          <a:bodyPr/>
+          <a:bodyPr wrap="square"/>
           <a:lstStyle/>
           <a:p>
+            <a:pPr marL="342900" indent="-342900">
+              <a:buFont typeface="Arial"/>
+              <a:buChar char="•"/>
+            </a:pPr>
             <a:r>
-              <a:t>Second slide body text</a:t>
+              <a:rPr lang="en-US" sz="2000"/>
+              <a:t>Second slide — page count must be 2</a:t>
             </a:r>
           </a:p>
         </p:txBody>
       </p:sp>
     </p:spTree>
   </p:cSld>
+  <p:clrMapOvr>
+    <a:masterClrMapping/>
+  </p:clrMapOvr>
 </p:sld>
+</file>
+
+<file path=ppt/theme/theme1.xml><?xml version="1.0" encoding="utf-8"?>
+<a:theme xmlns:a="http://schemas.openxmlformats.org/drawingml/2006/main" name="Spike">
+  <a:themeElements>
+    <a:clrScheme name="Spike">
+      <a:dk1>
+        <a:sysClr val="windowText" lastClr="000000"/>
+      </a:dk1>
+      <a:lt1>
+        <a:sysClr val="window" lastClr="FFFFFF"/>
+      </a:lt1>
+      <a:dk2>
+        <a:srgbClr val="1F497D"/>
+      </a:dk2>
+      <a:lt2>
+        <a:srgbClr val="EEECE1"/>
+      </a:lt2>
+      <a:accent1>
+        <a:srgbClr val="4F81BD"/>
+      </a:accent1>
+      <a:accent2>
+        <a:srgbClr val="C0504D"/>
+      </a:accent2>
+      <a:accent3>
+        <a:srgbClr val="9BBB59"/>
+      </a:accent3>
+      <a:accent4>
+        <a:srgbClr val="8064A2"/>
+      </a:accent4>
+      <a:accent5>
+        <a:srgbClr val="4BACC6"/>
+      </a:accent5>
+      <a:accent6>
+        <a:srgbClr val="F79646"/>
+      </a:accent6>
+      <a:hlink>
+        <a:srgbClr val="0000FF"/>
+      </a:hlink>
+      <a:folHlink>
+        <a:srgbClr val="800080"/>
+      </a:folHlink>
+    </a:clrScheme>
+    <a:fontScheme name="Spike">
+      <a:majorFont>
+        <a:latin typeface="Calibri"/>
+        <a:ea typeface=""/>
+        <a:cs typeface=""/>
+      </a:majorFont>
+      <a:minorFont>
+        <a:latin typeface="Calibri"/>
+        <a:ea typeface=""/>
+        <a:cs typeface=""/>
+      </a:minorFont>
+    </a:fontScheme>
+    <a:fmtScheme name="Spike">
+      <a:fillStyleLst>
+        <a:solidFill>
+          <a:schemeClr val="phClr"/>
+        </a:solidFill>
+        <a:solidFill>
+          <a:schemeClr val="phClr"/>
+        </a:solidFill>
+        <a:solidFill>
+          <a:schemeClr val="phClr"/>
+        </a:solidFill>
+      </a:fillStyleLst>
+      <a:lnStyleLst>
+        <a:ln w="9525">
+          <a:solidFill>
+            <a:schemeClr val="phClr"/>
+          </a:solidFill>
+        </a:ln>
+        <a:ln w="9525">
+          <a:solidFill>
+            <a:schemeClr val="phClr"/>
+          </a:solidFill>
+        </a:ln>
+        <a:ln w="9525">
+          <a:solidFill>
+            <a:schemeClr val="phClr"/>
+          </a:solidFill>
+        </a:ln>
+      </a:lnStyleLst>
+      <a:effectStyleLst>
+        <a:effectStyle>
+          <a:effectLst/>
+        </a:effectStyle>
+        <a:effectStyle>
+          <a:effectLst/>
+        </a:effectStyle>
+        <a:effectStyle>
+          <a:effectLst/>
+        </a:effectStyle>
+      </a:effectStyleLst>
+      <a:bgFillStyleLst>
+        <a:solidFill>
+          <a:schemeClr val="phClr"/>
+        </a:solidFill>
+        <a:solidFill>
+          <a:schemeClr val="phClr"/>
+        </a:solidFill>
+        <a:solidFill>
+          <a:schemeClr val="phClr"/>
+        </a:solidFill>
+      </a:bgFillStyleLst>
+    </a:fmtScheme>
+  </a:themeElements>
+</a:theme>
 </file>
</xml_diff>